<commit_message>
Proofread snli with Japanese proofreading skill
</commit_message>
<xml_diff>
--- a/slides/datasets-in-10-minutes-snli.pptx
+++ b/slides/datasets-in-10-minutes-snli.pptx
@@ -8943,7 +8943,7 @@
                 <a:ea typeface="Noto Sans CJK JP"/>
                 <a:cs typeface="Noto Sans"/>
               </a:rPr>
-              <a:t>Stanford Natural Language Inference Corpusとして、570,152組を収録し、2015年のEMNLPで発表された。</a:t>
+              <a:t>Stanford Natural Language Inference Corpusとして570,152組が収録され、2015年のEMNLPで発表された。</a:t>
             </a:r>
           </a:p>
         </p:txBody>
@@ -9290,7 +9290,7 @@
                 <a:ea typeface="Noto Sans CJK JP"/>
                 <a:cs typeface="Noto Sans"/>
               </a:rPr>
-              <a:t>作業者には写真を見せず、その説明文だけを提示した。同じ写真の状況について、確実に真・真かもしれない・確実に偽の文を各1つ書いた。</a:t>
+              <a:t>作業者には写真を見せず、その説明文だけを提示した。作業者は同じ写真の状況について、確実に真・真かもしれない・確実に偽の文を各1つ書いた。</a:t>
             </a:r>
           </a:p>
           <a:p>
@@ -9608,7 +9608,7 @@
                           <a:ea typeface="Noto Sans CJK JP"/>
                           <a:cs typeface="Noto Sans"/>
                         </a:rPr>
-                        <a:t>判定者</a:t>
+                        <a:t>区分</a:t>
                       </a:r>
                     </a:p>
                   </a:txBody>
@@ -14255,7 +14255,7 @@
         <p:spPr>
           <a:xfrm>
             <a:off x="548640" y="1787634"/>
-            <a:ext cx="8046720" cy="1552002"/>
+            <a:ext cx="8046720" cy="1755202"/>
           </a:xfrm>
           <a:prstGeom prst="rect">
             <a:avLst/>
@@ -14359,7 +14359,7 @@
         </p:nvSpPr>
         <p:spPr>
           <a:xfrm>
-            <a:off x="548640" y="3517036"/>
+            <a:off x="548640" y="3720236"/>
             <a:ext cx="8046720" cy="1073251"/>
           </a:xfrm>
           <a:prstGeom prst="rect">
@@ -14402,7 +14402,7 @@
                 <a:ea typeface="Noto Sans CJK JP"/>
                 <a:cs typeface="Noto Sans"/>
               </a:rPr>
-              <a:t>仮説は “The people who are shown are not all doing the exact same thing.”正解は含意。</a:t>
+              <a:t>仮説は “The people who are shown are not all doing the exact same thing.” で、正解は含意。</a:t>
             </a:r>
             <a:endParaRPr sz="1700" lang="ja-JP">
               <a:latin typeface="Noto Sans"/>
@@ -16818,7 +16818,7 @@
                 <a:ea typeface="Noto Sans CJK JP"/>
                 <a:cs typeface="Noto Sans"/>
               </a:rPr>
-              <a:t>いずれもSNLIの学習用で学習し、テスト用で評価した </a:t>
+              <a:t>いずれもSNLIの学習データで学習し、テストデータで評価した </a:t>
             </a:r>
             <a:r>
               <a:rPr sz="1900" lang="ja-JP">
@@ -18633,7 +18633,7 @@
                 <a:ea typeface="Noto Sans CJK JP"/>
                 <a:cs typeface="Noto Sans"/>
               </a:rPr>
-              <a:t>仮説だけを使う分類器で約67%という報告がある。</a:t>
+              <a:t>仮説文だけを使う分類器で正解率約67%という報告がある。</a:t>
             </a:r>
             <a:endParaRPr sz="2200" lang="ja-JP">
               <a:latin typeface="Noto Sans"/>
@@ -19317,7 +19317,7 @@
                 <a:ea typeface="Noto Sans CJK JP"/>
                 <a:cs typeface="Noto Sans"/>
               </a:rPr>
-              <a:t>SNLIは写真説明を扱った。これに対し、会話・小説など10ジャンルへ広げた </a:t>
+              <a:t>写真説明を扱ったSNLIに対し、会話・小説など10ジャンルへ対象を広げた </a:t>
             </a:r>
             <a:r>
               <a:rPr sz="2300" lang="ja-JP">
@@ -19367,7 +19367,7 @@
                 <a:ea typeface="Noto Sans CJK JP"/>
                 <a:cs typeface="Noto Sans"/>
               </a:rPr>
-              <a:t>さらに、未知のジャンルへの汎化も評価する。</a:t>
+              <a:t>さらに、未知のジャンルへの汎化性能も評価できる。</a:t>
             </a:r>
             <a:endParaRPr sz="2300" lang="ja-JP">
               <a:latin typeface="Noto Sans"/>
@@ -20112,7 +20112,7 @@
                 <a:ea typeface="Noto Sans CJK JP"/>
                 <a:cs typeface="Noto Sans"/>
               </a:rPr>
-              <a:t>モデルの予測を作業者へ返し、難しい例を集める。この例でモデルを学び直す工程を繰り返す。</a:t>
+              <a:t>モデルの予測を作業者へ返し、難しい例を集める。これらの例でモデルを学習し直す工程を繰り返す。</a:t>
             </a:r>
           </a:p>
           <a:p>
@@ -23454,7 +23454,7 @@
                 <a:ea typeface="Noto Sans CJK JP"/>
                 <a:cs typeface="Noto Sans"/>
               </a:rPr>
-              <a:t>第一著者のSamuel R. Bowmanは自然言語推論を研究する。</a:t>
+              <a:t>第一著者のSamuel R. Bowmanは自然言語推論を研究している。</a:t>
             </a:r>
             <a:endParaRPr sz="2000" lang="ja-JP">
               <a:latin typeface="Noto Sans"/>
@@ -23550,7 +23550,7 @@
                 <a:ea typeface="Noto Sans CJK JP"/>
                 <a:cs typeface="Noto Sans"/>
               </a:rPr>
-              <a:t>最終著者のChristopher D. Manningは単語表現などを研究する。</a:t>
+              <a:t>最終著者のChristopher D. Manningは単語表現などを研究している。</a:t>
             </a:r>
             <a:endParaRPr sz="2000" lang="ja-JP">
               <a:latin typeface="Noto Sans"/>
@@ -31058,7 +31058,7 @@
                 <a:ea typeface="Noto Sans CJK JP"/>
                 <a:cs typeface="Noto Sans"/>
               </a:rPr>
-              <a:t>文長を集計した版・分割と文対数</a:t>
+              <a:t>文長集計の対象データと集計条件</a:t>
             </a:r>
             <a:endParaRPr sz="2800" lang="ja-JP">
               <a:latin typeface="Noto Sans"/>
@@ -31222,7 +31222,7 @@
                 <a:ea typeface="Noto Sans CJK JP"/>
                 <a:cs typeface="Noto Sans"/>
               </a:rPr>
-              <a:t>正解付き569,033組を使い、ラベルが「-」の組は除く。</a:t>
+              <a:t>正解付き569,033組を使い、ラベルが「-」の組は除いた。</a:t>
             </a:r>
             <a:endParaRPr sz="2200" lang="ja-JP">
               <a:latin typeface="Noto Sans"/>
@@ -31278,7 +31278,7 @@
                 <a:ea typeface="Noto Sans CJK JP"/>
                 <a:cs typeface="Noto Sans"/>
               </a:rPr>
-              <a:t>Pythonのlen()で空白・句読点を含むUnicode文字を数える。</a:t>
+              <a:t>Pythonのlen()で空白・句読点を含むUnicode文字を数えた。</a:t>
             </a:r>
             <a:endParaRPr sz="2200" lang="ja-JP">
               <a:latin typeface="Noto Sans"/>
@@ -31306,7 +31306,7 @@
                 <a:ea typeface="Noto Sans CJK JP"/>
                 <a:cs typeface="Noto Sans"/>
               </a:rPr>
-              <a:t>str.split()で空白区切りの単語を数える。</a:t>
+              <a:t>str.split()で空白区切りの単語を数えた。</a:t>
             </a:r>
             <a:endParaRPr sz="2200" lang="ja-JP">
               <a:latin typeface="Noto Sans"/>
@@ -31334,7 +31334,7 @@
                 <a:ea typeface="Noto Sans CJK JP"/>
                 <a:cs typeface="Noto Sans"/>
               </a:rPr>
-              <a:t>前提は文対ごとに繰り返し数える。</a:t>
+              <a:t>前提は文対ごとに重複して数えた。</a:t>
             </a:r>
             <a:endParaRPr sz="2200" lang="ja-JP">
               <a:latin typeface="Noto Sans"/>
@@ -33499,7 +33499,7 @@
                           <a:ea typeface="Noto Sans CJK JP"/>
                           <a:cs typeface="Noto Sans"/>
                         </a:rPr>
-                        <a:t>中央</a:t>
+                        <a:t>中央値</a:t>
                       </a:r>
                       <a:endParaRPr sz="1600" lang="ja-JP">
                         <a:latin typeface="Noto Sans"/>
@@ -34960,7 +34960,7 @@
                 <a:ea typeface="Noto Sans CJK JP"/>
                 <a:cs typeface="Noto Sans"/>
               </a:rPr>
-              <a:t>前提を文対ごとに数える。</a:t>
+              <a:t>前提文は文対ごとに集計。</a:t>
             </a:r>
             <a:endParaRPr sz="1700" lang="ja-JP">
               <a:latin typeface="Noto Sans"/>
@@ -35565,7 +35565,7 @@
                           <a:ea typeface="Noto Sans CJK JP"/>
                           <a:cs typeface="Noto Sans"/>
                         </a:rPr>
-                        <a:t>中央</a:t>
+                        <a:t>中央値</a:t>
                       </a:r>
                       <a:endParaRPr sz="1600" lang="ja-JP">
                         <a:latin typeface="Noto Sans"/>
@@ -37481,7 +37481,7 @@
                 <a:ea typeface="Noto Sans CJK JP"/>
                 <a:cs typeface="Noto Sans"/>
               </a:rPr>
-              <a:t>分割別の前提の単語数</a:t>
+              <a:t>分割別の前提文の単語数</a:t>
             </a:r>
             <a:endParaRPr sz="2800" lang="ja-JP">
               <a:latin typeface="Noto Sans"/>
@@ -37873,7 +37873,7 @@
                           <a:ea typeface="Noto Sans CJK JP"/>
                           <a:cs typeface="Noto Sans"/>
                         </a:rPr>
-                        <a:t>中央</a:t>
+                        <a:t>中央値</a:t>
                       </a:r>
                       <a:endParaRPr sz="2400" lang="ja-JP">
                         <a:latin typeface="Noto Sans"/>
@@ -40269,7 +40269,7 @@
                 <a:ea typeface="Noto Sans CJK JP"/>
                 <a:cs typeface="Noto Sans"/>
               </a:rPr>
-              <a:t>分割別の仮説の単語数</a:t>
+              <a:t>分割別の仮説文の単語数</a:t>
             </a:r>
             <a:endParaRPr sz="2800" lang="ja-JP">
               <a:latin typeface="Noto Sans"/>
@@ -40661,7 +40661,7 @@
                           <a:ea typeface="Noto Sans CJK JP"/>
                           <a:cs typeface="Noto Sans"/>
                         </a:rPr>
-                        <a:t>中央</a:t>
+                        <a:t>中央値</a:t>
                       </a:r>
                       <a:endParaRPr sz="2400" lang="ja-JP">
                         <a:latin typeface="Noto Sans"/>
@@ -42367,7 +42367,7 @@
                 <a:ea typeface="Noto Sans CJK JP"/>
                 <a:cs typeface="Noto Sans"/>
               </a:rPr>
-              <a:t>前提は “A doberman bites a large blue ball.”正解は矛盾。仮説には前提と無関係な描写が多い。</a:t>
+              <a:t>前提は“A doberman bites a large blue ball.”で、正解は矛盾。仮説には前提と無関係な描写が多い。</a:t>
             </a:r>
             <a:endParaRPr sz="1700" lang="ja-JP">
               <a:latin typeface="Noto Sans"/>
@@ -44594,7 +44594,7 @@
                 <a:ea typeface="Noto Sans CJK JP"/>
                 <a:cs typeface="Noto Sans"/>
               </a:rPr>
-              <a:t>公式のJSONLにはsentence1、sentence2、gold_labelなどを含む。</a:t>
+              <a:t>公式のJSONLにはsentence1、sentence2、gold_labelなどが含まれる。</a:t>
             </a:r>
             <a:endParaRPr sz="1700" lang="ja-JP">
               <a:latin typeface="Noto Sans"/>

</xml_diff>

<commit_message>
slides(snli): refine Japanese wording and pair translations
</commit_message>
<xml_diff>
--- a/slides/datasets-in-10-minutes-snli.pptx
+++ b/slides/datasets-in-10-minutes-snli.pptx
@@ -16302,7 +16302,7 @@
                           <a:ea typeface="Noto Sans CJK JP"/>
                           <a:cs typeface="Noto Sans"/>
                         </a:rPr>
-                        <a:t>原著のモデル</a:t>
+                        <a:t>初期モデル</a:t>
                       </a:r>
                       <a:endParaRPr sz="2200" lang="ja-JP">
                         <a:latin typeface="Noto Sans"/>
@@ -45304,7 +45304,7 @@
                 <a:ea typeface="Noto Sans CJK JP"/>
                 <a:cs typeface="Noto Sans"/>
               </a:rPr>
-              <a:t>SNLIの原著論文。文対の収集、3種類の関係の注釈と検証、初期モデルの評価を報告する。</a:t>
+              <a:t>文対の収集、3種類の関係の注釈と検証、初期モデルの評価を報告する。</a:t>
             </a:r>
           </a:p>
         </p:txBody>
@@ -45493,7 +45493,7 @@
                 <a:ea typeface="Noto Sans CJK JP"/>
                 <a:cs typeface="Noto Sans"/>
               </a:rPr>
-              <a:t>MultiNLIの原著論文。10ジャンルの文対を収集し、分野内・分野間の汎化を評価する。</a:t>
+              <a:t>10ジャンルの文対を収集し、分野内・分野間の汎化を評価する。</a:t>
             </a:r>
           </a:p>
         </p:txBody>
@@ -46976,7 +46976,7 @@
                 <a:ea typeface="Noto Sans CJK JP"/>
                 <a:cs typeface="Noto Sans"/>
               </a:rPr>
-              <a:t>Sentence-BERTの原著論文。BERTから文埋め込みを生成し、文間の類似度を計算する。</a:t>
+              <a:t>BERTから文埋め込みを生成し、文間の類似度を計算する。</a:t>
             </a:r>
           </a:p>
         </p:txBody>
@@ -47669,7 +47669,7 @@
                 <a:ea typeface="Noto Sans CJK JP"/>
                 <a:cs typeface="Noto Sans"/>
               </a:rPr>
-              <a:t>ANLIの原著論文。人がモデルを誤らせる文対を作る反復的なデータ収集を提案する。</a:t>
+              <a:t>人がモデルを誤らせる文対を作る反復的なデータ収集を提案する。</a:t>
             </a:r>
           </a:p>
         </p:txBody>

</xml_diff>

<commit_message>
Improve snli answer visibility and citation wording
</commit_message>
<xml_diff>
--- a/slides/datasets-in-10-minutes-snli.pptx
+++ b/slides/datasets-in-10-minutes-snli.pptx
@@ -7820,7 +7820,7 @@
         <p:spPr>
           <a:xfrm>
             <a:off x="548640" y="3147771"/>
-            <a:ext cx="8046720" cy="320040"/>
+            <a:ext cx="8046720" cy="400743"/>
           </a:xfrm>
           <a:prstGeom prst="rect">
             <a:avLst/>
@@ -7853,9 +7853,9 @@
               </a:defRPr>
             </a:pPr>
             <a:r>
-              <a:rPr sz="2100" b="0" lang="ja-JP">
-                <a:solidFill>
-                  <a:srgbClr val="B13731"/>
+              <a:rPr sz="2100" b="1" lang="ja-JP">
+                <a:solidFill>
+                  <a:schemeClr val="accent1"/>
                 </a:solidFill>
                 <a:latin typeface="Noto Sans"/>
                 <a:ea typeface="Noto Sans CJK JP"/>
@@ -24444,7 +24444,7 @@
         <p:spPr>
           <a:xfrm>
             <a:off x="548640" y="3433521"/>
-            <a:ext cx="8046720" cy="320040"/>
+            <a:ext cx="8046720" cy="400832"/>
           </a:xfrm>
           <a:prstGeom prst="rect">
             <a:avLst/>
@@ -24477,9 +24477,9 @@
               </a:defRPr>
             </a:pPr>
             <a:r>
-              <a:rPr sz="2100" b="0" lang="ja-JP">
-                <a:solidFill>
-                  <a:srgbClr val="B13731"/>
+              <a:rPr sz="2100" b="1" lang="ja-JP">
+                <a:solidFill>
+                  <a:schemeClr val="accent1"/>
                 </a:solidFill>
                 <a:latin typeface="Noto Sans"/>
                 <a:ea typeface="Noto Sans CJK JP"/>
@@ -25108,7 +25108,7 @@
         <p:spPr>
           <a:xfrm>
             <a:off x="548640" y="3147771"/>
-            <a:ext cx="8046720" cy="320040"/>
+            <a:ext cx="8046720" cy="400743"/>
           </a:xfrm>
           <a:prstGeom prst="rect">
             <a:avLst/>
@@ -25141,9 +25141,9 @@
               </a:defRPr>
             </a:pPr>
             <a:r>
-              <a:rPr sz="2100" b="0" lang="ja-JP">
-                <a:solidFill>
-                  <a:srgbClr val="B13731"/>
+              <a:rPr sz="2100" b="1" lang="ja-JP">
+                <a:solidFill>
+                  <a:schemeClr val="accent1"/>
                 </a:solidFill>
                 <a:latin typeface="Noto Sans"/>
                 <a:ea typeface="Noto Sans CJK JP"/>
@@ -25772,7 +25772,7 @@
         <p:spPr>
           <a:xfrm>
             <a:off x="548640" y="3147771"/>
-            <a:ext cx="8046720" cy="320040"/>
+            <a:ext cx="8046720" cy="400743"/>
           </a:xfrm>
           <a:prstGeom prst="rect">
             <a:avLst/>
@@ -25805,9 +25805,9 @@
               </a:defRPr>
             </a:pPr>
             <a:r>
-              <a:rPr sz="2100" b="0" lang="ja-JP">
-                <a:solidFill>
-                  <a:srgbClr val="B13731"/>
+              <a:rPr sz="2100" b="1" lang="ja-JP">
+                <a:solidFill>
+                  <a:schemeClr val="accent1"/>
                 </a:solidFill>
                 <a:latin typeface="Noto Sans"/>
                 <a:ea typeface="Noto Sans CJK JP"/>
@@ -26436,7 +26436,7 @@
         <p:spPr>
           <a:xfrm>
             <a:off x="548640" y="3147771"/>
-            <a:ext cx="8046720" cy="320040"/>
+            <a:ext cx="8046720" cy="400743"/>
           </a:xfrm>
           <a:prstGeom prst="rect">
             <a:avLst/>
@@ -26469,9 +26469,9 @@
               </a:defRPr>
             </a:pPr>
             <a:r>
-              <a:rPr sz="2100" b="0" lang="ja-JP">
-                <a:solidFill>
-                  <a:srgbClr val="B13731"/>
+              <a:rPr sz="2100" b="1" lang="ja-JP">
+                <a:solidFill>
+                  <a:schemeClr val="accent1"/>
                 </a:solidFill>
                 <a:latin typeface="Noto Sans"/>
                 <a:ea typeface="Noto Sans CJK JP"/>
@@ -27100,7 +27100,7 @@
         <p:spPr>
           <a:xfrm>
             <a:off x="548640" y="3147771"/>
-            <a:ext cx="8046720" cy="320040"/>
+            <a:ext cx="8046720" cy="400743"/>
           </a:xfrm>
           <a:prstGeom prst="rect">
             <a:avLst/>
@@ -27133,9 +27133,9 @@
               </a:defRPr>
             </a:pPr>
             <a:r>
-              <a:rPr sz="2100" b="0" lang="ja-JP">
-                <a:solidFill>
-                  <a:srgbClr val="B13731"/>
+              <a:rPr sz="2100" b="1" lang="ja-JP">
+                <a:solidFill>
+                  <a:schemeClr val="accent1"/>
                 </a:solidFill>
                 <a:latin typeface="Noto Sans"/>
                 <a:ea typeface="Noto Sans CJK JP"/>
@@ -27764,7 +27764,7 @@
         <p:spPr>
           <a:xfrm>
             <a:off x="548640" y="3433521"/>
-            <a:ext cx="8046720" cy="320040"/>
+            <a:ext cx="8046720" cy="400832"/>
           </a:xfrm>
           <a:prstGeom prst="rect">
             <a:avLst/>
@@ -27797,9 +27797,9 @@
               </a:defRPr>
             </a:pPr>
             <a:r>
-              <a:rPr sz="2100" b="0" lang="ja-JP">
-                <a:solidFill>
-                  <a:srgbClr val="B13731"/>
+              <a:rPr sz="2100" b="1" lang="ja-JP">
+                <a:solidFill>
+                  <a:schemeClr val="accent1"/>
                 </a:solidFill>
                 <a:latin typeface="Noto Sans"/>
                 <a:ea typeface="Noto Sans CJK JP"/>
@@ -28809,7 +28809,7 @@
         <p:spPr>
           <a:xfrm>
             <a:off x="548640" y="3147771"/>
-            <a:ext cx="8046720" cy="320040"/>
+            <a:ext cx="8046720" cy="400743"/>
           </a:xfrm>
           <a:prstGeom prst="rect">
             <a:avLst/>
@@ -28842,9 +28842,9 @@
               </a:defRPr>
             </a:pPr>
             <a:r>
-              <a:rPr sz="2100" b="0" lang="ja-JP">
-                <a:solidFill>
-                  <a:srgbClr val="B13731"/>
+              <a:rPr sz="2100" b="1" lang="ja-JP">
+                <a:solidFill>
+                  <a:schemeClr val="accent1"/>
                 </a:solidFill>
                 <a:latin typeface="Noto Sans"/>
                 <a:ea typeface="Noto Sans CJK JP"/>
@@ -29473,7 +29473,7 @@
         <p:spPr>
           <a:xfrm>
             <a:off x="548640" y="3147771"/>
-            <a:ext cx="8046720" cy="320040"/>
+            <a:ext cx="8046720" cy="400743"/>
           </a:xfrm>
           <a:prstGeom prst="rect">
             <a:avLst/>
@@ -29506,9 +29506,9 @@
               </a:defRPr>
             </a:pPr>
             <a:r>
-              <a:rPr sz="2100" b="0" lang="ja-JP">
-                <a:solidFill>
-                  <a:srgbClr val="B13731"/>
+              <a:rPr sz="2100" b="1" lang="ja-JP">
+                <a:solidFill>
+                  <a:schemeClr val="accent1"/>
                 </a:solidFill>
                 <a:latin typeface="Noto Sans"/>
                 <a:ea typeface="Noto Sans CJK JP"/>
@@ -30137,7 +30137,7 @@
         <p:spPr>
           <a:xfrm>
             <a:off x="548640" y="3147771"/>
-            <a:ext cx="8046720" cy="320040"/>
+            <a:ext cx="8046720" cy="400743"/>
           </a:xfrm>
           <a:prstGeom prst="rect">
             <a:avLst/>
@@ -30170,9 +30170,9 @@
               </a:defRPr>
             </a:pPr>
             <a:r>
-              <a:rPr sz="2100" b="0" lang="ja-JP">
-                <a:solidFill>
-                  <a:srgbClr val="B13731"/>
+              <a:rPr sz="2100" b="1" lang="ja-JP">
+                <a:solidFill>
+                  <a:schemeClr val="accent1"/>
                 </a:solidFill>
                 <a:latin typeface="Noto Sans"/>
                 <a:ea typeface="Noto Sans CJK JP"/>
@@ -30801,7 +30801,7 @@
         <p:spPr>
           <a:xfrm>
             <a:off x="548640" y="3433521"/>
-            <a:ext cx="8046720" cy="320040"/>
+            <a:ext cx="8046720" cy="400832"/>
           </a:xfrm>
           <a:prstGeom prst="rect">
             <a:avLst/>
@@ -30834,9 +30834,9 @@
               </a:defRPr>
             </a:pPr>
             <a:r>
-              <a:rPr sz="2100" b="0" lang="ja-JP">
-                <a:solidFill>
-                  <a:srgbClr val="B13731"/>
+              <a:rPr sz="2100" b="1" lang="ja-JP">
+                <a:solidFill>
+                  <a:schemeClr val="accent1"/>
                 </a:solidFill>
                 <a:latin typeface="Noto Sans"/>
                 <a:ea typeface="Noto Sans CJK JP"/>
@@ -39701,7 +39701,7 @@
         <p:spPr>
           <a:xfrm>
             <a:off x="548640" y="3147771"/>
-            <a:ext cx="8046720" cy="320040"/>
+            <a:ext cx="8046720" cy="400743"/>
           </a:xfrm>
           <a:prstGeom prst="rect">
             <a:avLst/>
@@ -39734,9 +39734,9 @@
               </a:defRPr>
             </a:pPr>
             <a:r>
-              <a:rPr sz="2100" b="0" lang="ja-JP">
-                <a:solidFill>
-                  <a:srgbClr val="B13731"/>
+              <a:rPr sz="2100" b="1" lang="ja-JP">
+                <a:solidFill>
+                  <a:schemeClr val="accent1"/>
                 </a:solidFill>
                 <a:latin typeface="Noto Sans"/>
                 <a:ea typeface="Noto Sans CJK JP"/>
@@ -44386,9 +44386,20 @@
                 <a:latin typeface="Liberation Mono"/>
                 <a:ea typeface="Noto Sans CJK JP"/>
                 <a:cs typeface="Noto Sans"/>
-                <a:hlinkClick r:id="rId3"/>
-              </a:rPr>
-              <a:t>https://nlp.stanford.edu/projects/snli/snli_1.0.zip"</a:t>
+                <a:hlinkClick r:id="rId4"/>
+              </a:rPr>
+              <a:t>https://nlp.stanford.edu/projects/snli/snli_1.0.zip</a:t>
+            </a:r>
+            <a:r>
+              <a:rPr sz="1400" lang="ja-JP">
+                <a:solidFill>
+                  <a:srgbClr val="303437"/>
+                </a:solidFill>
+                <a:latin typeface="Liberation Mono"/>
+                <a:ea typeface="Noto Sans CJK JP"/>
+                <a:cs typeface="Noto Sans"/>
+              </a:rPr>
+              <a:t>"</a:t>
             </a:r>
           </a:p>
           <a:p>
@@ -46567,7 +46578,7 @@
         <p:spPr>
           <a:xfrm>
             <a:off x="548640" y="3147771"/>
-            <a:ext cx="8046720" cy="320040"/>
+            <a:ext cx="8046720" cy="400743"/>
           </a:xfrm>
           <a:prstGeom prst="rect">
             <a:avLst/>
@@ -46600,9 +46611,9 @@
               </a:defRPr>
             </a:pPr>
             <a:r>
-              <a:rPr sz="2100" b="0" lang="ja-JP">
-                <a:solidFill>
-                  <a:srgbClr val="B13731"/>
+              <a:rPr sz="2100" b="1" lang="ja-JP">
+                <a:solidFill>
+                  <a:schemeClr val="accent1"/>
                 </a:solidFill>
                 <a:latin typeface="Noto Sans"/>
                 <a:ea typeface="Noto Sans CJK JP"/>
@@ -48511,7 +48522,7 @@
         <p:spPr>
           <a:xfrm>
             <a:off x="548640" y="3433521"/>
-            <a:ext cx="8046720" cy="320040"/>
+            <a:ext cx="8046720" cy="400832"/>
           </a:xfrm>
           <a:prstGeom prst="rect">
             <a:avLst/>
@@ -48544,9 +48555,9 @@
               </a:defRPr>
             </a:pPr>
             <a:r>
-              <a:rPr sz="2100" b="0" lang="ja-JP">
-                <a:solidFill>
-                  <a:srgbClr val="B13731"/>
+              <a:rPr sz="2100" b="1" lang="ja-JP">
+                <a:solidFill>
+                  <a:schemeClr val="accent1"/>
                 </a:solidFill>
                 <a:latin typeface="Noto Sans"/>
                 <a:ea typeface="Noto Sans CJK JP"/>

</xml_diff>